<commit_message>
Topic 2: stars on the lesson decks, calendar matched to the district plan, review practice test
- General, 504, IEP and catch-up decks mark the 150-day guide's essential
  activities with "★ Essential" (504 "Today's plan" too); Lesson 4 has none.
- Pacing calendar follows the AHS collaborative planning guide: review Mon Nov 2,
  End of Topic 2 Assessment Tue Nov 3, retakes Wed Nov 4. Lesson 3 moves to
  Oct 28-29, Lesson 4 is taught in brief on review day and finished on Nov 4;
  Skills Practice quizzes become homework. Catch-up deck dates follow.
- New Topic 2 Review practice test (General, IEP, 504): 14 items in the test's
  order and style; linked from the calendar and the home page.

Co-Authored-By: Claude Opus 5.5 (1M context) <noreply@anthropic.com>
</commit_message>
<xml_diff>
--- a/IEP/t2-lesson1-transforming-linear-functions-IEP-catchup.pptx
+++ b/IEP/t2-lesson1-transforming-linear-functions-IEP-catchup.pptx
@@ -5018,7 +5018,7 @@
                 <a:latin typeface="Segoe UI"/>
                 <a:cs typeface="Segoe UI"/>
               </a:rPr>
-              <a:t xml:space="preserve">I do · Watch me</a:t>
+              <a:t xml:space="preserve">I do · Watch me · ★ Essential</a:t>
             </a:r>
             <a:endParaRPr lang="en-US" sz="1200" dirty="0"/>
           </a:p>
@@ -9241,7 +9241,7 @@
                 <a:latin typeface="Segoe UI"/>
                 <a:cs typeface="Segoe UI"/>
               </a:rPr>
-              <a:t xml:space="preserve">We do · Together</a:t>
+              <a:t xml:space="preserve">We do · Together · ★ Essential</a:t>
             </a:r>
             <a:endParaRPr lang="en-US" sz="1200" dirty="0"/>
           </a:p>
@@ -18872,7 +18872,7 @@
                 <a:latin typeface="Segoe UI"/>
                 <a:cs typeface="Segoe UI"/>
               </a:rPr>
-              <a:t xml:space="preserve">We do · Parallel line</a:t>
+              <a:t xml:space="preserve">We do · Parallel line · ★ Essential</a:t>
             </a:r>
             <a:endParaRPr lang="en-US" sz="1200" dirty="0"/>
           </a:p>
@@ -19805,7 +19805,7 @@
                 <a:latin typeface="Segoe UI"/>
                 <a:cs typeface="Segoe UI"/>
               </a:rPr>
-              <a:t xml:space="preserve">You do · Try it</a:t>
+              <a:t xml:space="preserve">You do · Try it · ★ Essential</a:t>
             </a:r>
             <a:endParaRPr lang="en-US" sz="1200" dirty="0"/>
           </a:p>
@@ -20611,7 +20611,7 @@
                 <a:latin typeface="Segoe UI"/>
                 <a:cs typeface="Segoe UI"/>
               </a:rPr>
-              <a:t xml:space="preserve">Check it · Step by step</a:t>
+              <a:t xml:space="preserve">Check it · Step by step · ★ Essential</a:t>
             </a:r>
             <a:endParaRPr lang="en-US" sz="1200" dirty="0"/>
           </a:p>
@@ -23007,7 +23007,7 @@
                 <a:latin typeface="Segoe UI"/>
                 <a:cs typeface="Segoe UI"/>
               </a:rPr>
-              <a:t xml:space="preserve">I do · Stretch</a:t>
+              <a:t xml:space="preserve">I do · Stretch · ★ Essential</a:t>
             </a:r>
             <a:endParaRPr lang="en-US" sz="1200" dirty="0"/>
           </a:p>
@@ -36389,7 +36389,7 @@
                 <a:latin typeface="Segoe UI"/>
                 <a:cs typeface="Segoe UI"/>
               </a:rPr>
-              <a:t xml:space="preserve">You do · Try it</a:t>
+              <a:t xml:space="preserve">You do · Try it · ★ Essential</a:t>
             </a:r>
             <a:endParaRPr lang="en-US" sz="1200" dirty="0"/>
           </a:p>
@@ -37401,7 +37401,7 @@
                 <a:latin typeface="Segoe UI"/>
                 <a:cs typeface="Segoe UI"/>
               </a:rPr>
-              <a:t xml:space="preserve">Check it · Step by step</a:t>
+              <a:t xml:space="preserve">Check it · Step by step · ★ Essential</a:t>
             </a:r>
             <a:endParaRPr lang="en-US" sz="1200" dirty="0"/>
           </a:p>

</xml_diff>